<commit_message>
Atualiza documentacao do projeto
</commit_message>
<xml_diff>
--- a/Documentation/Slide app Rpojeto Plot V2.pptx
+++ b/Documentation/Slide app Rpojeto Plot V2.pptx
@@ -23,26 +23,24 @@
   <p:notesSz cx="8229600" cy="14630400"/>
   <p:embeddedFontLst>
     <p:embeddedFont>
-      <p:font typeface="Libre Baskerville" panose="020B0604020202020204" charset="0"/>
+      <p:font typeface="Consolas" panose="020B0609020204030204" pitchFamily="49" charset="0"/>
       <p:regular r:id="rId13"/>
+      <p:bold r:id="rId14"/>
+      <p:italic r:id="rId15"/>
+      <p:boldItalic r:id="rId16"/>
     </p:embeddedFont>
     <p:embeddedFont>
-      <p:font typeface="Consolas" panose="020B0609020204030204" pitchFamily="49" charset="0"/>
-      <p:regular r:id="rId14"/>
-      <p:bold r:id="rId15"/>
-      <p:italic r:id="rId16"/>
-      <p:boldItalic r:id="rId17"/>
+      <p:font typeface="DM Sans" pitchFamily="2" charset="0"/>
+      <p:regular r:id="rId17"/>
+      <p:bold r:id="rId18"/>
+      <p:italic r:id="rId19"/>
+      <p:boldItalic r:id="rId20"/>
     </p:embeddedFont>
     <p:embeddedFont>
-      <p:font typeface="Calibri" panose="020F0502020204030204" pitchFamily="34" charset="0"/>
-      <p:regular r:id="rId18"/>
-      <p:bold r:id="rId19"/>
-      <p:italic r:id="rId20"/>
-      <p:boldItalic r:id="rId21"/>
-    </p:embeddedFont>
-    <p:embeddedFont>
-      <p:font typeface="DM Sans" panose="020B0604020202020204" charset="0"/>
-      <p:regular r:id="rId22"/>
+      <p:font typeface="Libre Baskerville" panose="02000000000000000000" pitchFamily="2" charset="0"/>
+      <p:regular r:id="rId21"/>
+      <p:bold r:id="rId22"/>
+      <p:italic r:id="rId23"/>
     </p:embeddedFont>
   </p:embeddedFontLst>
   <p:defaultTextStyle>
@@ -140,7 +138,33 @@
       </a:defRPr>
     </a:lvl9pPr>
   </p:defaultTextStyle>
+  <p:extLst>
+    <p:ext uri="{EFAFB233-063F-42B5-8137-9DF3F51BA10A}">
+      <p15:sldGuideLst xmlns:p15="http://schemas.microsoft.com/office/powerpoint/2012/main">
+        <p15:guide id="1" orient="horz" pos="2592">
+          <p15:clr>
+            <a:srgbClr val="A4A3A4"/>
+          </p15:clr>
+        </p15:guide>
+        <p15:guide id="2" pos="4608">
+          <p15:clr>
+            <a:srgbClr val="A4A3A4"/>
+          </p15:clr>
+        </p15:guide>
+      </p15:sldGuideLst>
+    </p:ext>
+  </p:extLst>
 </p:presentation>
+</file>
+
+<file path=ppt/revisionInfo.xml><?xml version="1.0" encoding="utf-8"?>
+<p1510:revInfo xmlns:a="http://schemas.openxmlformats.org/drawingml/2006/main" xmlns:r="http://schemas.openxmlformats.org/officeDocument/2006/relationships" xmlns:p1510="http://schemas.microsoft.com/office/powerpoint/2015/10/main">
+  <p1510:revLst>
+    <p1510:client id="{08794310-A34D-48BB-8F16-D60FC6B4D391}" v="89" dt="2026-06-12T00:03:36.208"/>
+    <p1510:client id="{2FE8D235-BA1D-4FA4-833F-9FB488D5C392}" v="15" dt="2026-06-11T13:23:04.952"/>
+    <p1510:client id="{7B0548D5-2A20-4EB8-BF1A-8ED760E68B1E}" v="95" dt="2026-06-10T20:11:36.586"/>
+  </p1510:revLst>
+</p1510:revInfo>
 </file>
 
 <file path=ppt/notesMasters/notesMaster1.xml><?xml version="1.0" encoding="utf-8"?>
@@ -225,7 +249,7 @@
           <a:p>
             <a:fld id="{582763C7-6F0B-4E97-A307-D3A6FEBDB61C}" type="datetimeFigureOut">
               <a:rPr lang="pt-BR" smtClean="0"/>
-              <a:t>28/04/2026</a:t>
+              <a:t>11/06/2026</a:t>
             </a:fld>
             <a:endParaRPr lang="pt-BR"/>
           </a:p>
@@ -289,38 +313,37 @@
           <a:p>
             <a:pPr lvl="0"/>
             <a:r>
-              <a:rPr lang="pt-BR" smtClean="0"/>
+              <a:rPr lang="pt-BR"/>
               <a:t>Clique para editar o texto mestre</a:t>
             </a:r>
           </a:p>
           <a:p>
             <a:pPr lvl="1"/>
             <a:r>
-              <a:rPr lang="pt-BR" smtClean="0"/>
+              <a:rPr lang="pt-BR"/>
               <a:t>Segundo nível</a:t>
             </a:r>
           </a:p>
           <a:p>
             <a:pPr lvl="2"/>
             <a:r>
-              <a:rPr lang="pt-BR" smtClean="0"/>
+              <a:rPr lang="pt-BR"/>
               <a:t>Terceiro nível</a:t>
             </a:r>
           </a:p>
           <a:p>
             <a:pPr lvl="3"/>
             <a:r>
-              <a:rPr lang="pt-BR" smtClean="0"/>
+              <a:rPr lang="pt-BR"/>
               <a:t>Quarto nível</a:t>
             </a:r>
           </a:p>
           <a:p>
             <a:pPr lvl="4"/>
             <a:r>
-              <a:rPr lang="pt-BR" smtClean="0"/>
+              <a:rPr lang="pt-BR"/>
               <a:t>Quinto nível</a:t>
             </a:r>
-            <a:endParaRPr lang="pt-BR"/>
           </a:p>
         </p:txBody>
       </p:sp>
@@ -2670,7 +2693,7 @@
               <a:buNone/>
             </a:pPr>
             <a:r>
-              <a:rPr lang="en-US" sz="6000" dirty="0" smtClean="0">
+              <a:rPr lang="en-US" sz="6000" dirty="0">
                 <a:solidFill>
                   <a:srgbClr val="5C4E3D"/>
                 </a:solidFill>
@@ -2860,7 +2883,7 @@
               <a:t>Curso de Análise e </a:t>
             </a:r>
             <a:r>
-              <a:rPr lang="en-US" dirty="0" err="1" smtClean="0">
+              <a:rPr lang="en-US" dirty="0" err="1">
                 <a:solidFill>
                   <a:srgbClr val="454240"/>
                 </a:solidFill>
@@ -2871,7 +2894,7 @@
               <a:t>Desenvolvimento</a:t>
             </a:r>
             <a:r>
-              <a:rPr lang="en-US" dirty="0" smtClean="0">
+              <a:rPr lang="en-US" dirty="0">
                 <a:solidFill>
                   <a:srgbClr val="454240"/>
                 </a:solidFill>
@@ -2882,7 +2905,7 @@
               <a:t> de </a:t>
             </a:r>
             <a:r>
-              <a:rPr lang="en-US" dirty="0" err="1" smtClean="0">
+              <a:rPr lang="en-US" dirty="0" err="1">
                 <a:solidFill>
                   <a:srgbClr val="454240"/>
                 </a:solidFill>
@@ -2969,13 +2992,6 @@
   <p:clrMapOvr>
     <a:masterClrMapping/>
   </p:clrMapOvr>
-  <p:timing>
-    <p:tnLst>
-      <p:par>
-        <p:cTn id="1" dur="indefinite" restart="never" nodeType="tmRoot"/>
-      </p:par>
-    </p:tnLst>
-  </p:timing>
 </p:sld>
 </file>
 
@@ -3373,13 +3389,6 @@
   <p:clrMapOvr>
     <a:masterClrMapping/>
   </p:clrMapOvr>
-  <p:timing>
-    <p:tnLst>
-      <p:par>
-        <p:cTn id="1" dur="indefinite" restart="never" nodeType="tmRoot"/>
-      </p:par>
-    </p:tnLst>
-  </p:timing>
 </p:sld>
 </file>
 
@@ -3560,7 +3569,7 @@
         <p:spPr>
           <a:xfrm>
             <a:off x="999768" y="4109680"/>
-            <a:ext cx="2480905" cy="310158"/>
+            <a:ext cx="2820539" cy="310158"/>
           </a:xfrm>
           <a:prstGeom prst="rect">
             <a:avLst/>
@@ -3578,7 +3587,7 @@
               </a:lnSpc>
             </a:pPr>
             <a:r>
-              <a:rPr lang="en-US" sz="1950" dirty="0" smtClean="0">
+              <a:rPr lang="en-US" sz="1950" dirty="0">
                 <a:solidFill>
                   <a:srgbClr val="454240"/>
                 </a:solidFill>
@@ -3589,7 +3598,7 @@
               <a:t>Interface do </a:t>
             </a:r>
             <a:r>
-              <a:rPr lang="en-US" sz="1950" dirty="0" err="1" smtClean="0">
+              <a:rPr lang="en-US" sz="1950" dirty="0" err="1">
                 <a:solidFill>
                   <a:srgbClr val="454240"/>
                 </a:solidFill>
@@ -3699,7 +3708,7 @@
               </a:lnSpc>
             </a:pPr>
             <a:r>
-              <a:rPr lang="en-US" sz="1950" dirty="0" err="1" smtClean="0">
+              <a:rPr lang="en-US" sz="1950" dirty="0" err="1">
                 <a:solidFill>
                   <a:srgbClr val="454240"/>
                 </a:solidFill>
@@ -3710,7 +3719,7 @@
               <a:t>Lógica</a:t>
             </a:r>
             <a:r>
-              <a:rPr lang="en-US" sz="1950" dirty="0" smtClean="0">
+              <a:rPr lang="en-US" sz="1950" dirty="0">
                 <a:solidFill>
                   <a:srgbClr val="454240"/>
                 </a:solidFill>
@@ -3721,7 +3730,7 @@
               <a:t> do </a:t>
             </a:r>
             <a:r>
-              <a:rPr lang="en-US" sz="1950" dirty="0" err="1" smtClean="0">
+              <a:rPr lang="en-US" sz="1950" dirty="0" err="1">
                 <a:solidFill>
                   <a:srgbClr val="454240"/>
                 </a:solidFill>
@@ -3779,35 +3788,21 @@
       </p:sp>
       <p:pic>
         <p:nvPicPr>
-          <p:cNvPr id="12" name="Imagem 11"/>
+          <p:cNvPr id="12" name="Imagem 11" descr="Uma imagem contendo Texto&#10;&#10;O conteúdo gerado por IA pode estar incorreto."/>
           <p:cNvPicPr/>
           <p:nvPr/>
         </p:nvPicPr>
         <p:blipFill>
-          <a:blip r:embed="rId3">
-            <a:extLst>
-              <a:ext uri="{BEBA8EAE-BF5A-486C-A8C5-ECC9F3942E4B}">
-                <a14:imgProps xmlns:a14="http://schemas.microsoft.com/office/drawing/2010/main">
-                  <a14:imgLayer r:embed="rId4">
-                    <a14:imgEffect>
-                      <a14:sharpenSoften amount="50000"/>
-                    </a14:imgEffect>
-                  </a14:imgLayer>
-                </a14:imgProps>
-              </a:ext>
-              <a:ext uri="{28A0092B-C50C-407E-A947-70E740481C1C}">
-                <a14:useLocalDpi xmlns:a14="http://schemas.microsoft.com/office/drawing/2010/main" val="0"/>
-              </a:ext>
-            </a:extLst>
-          </a:blip>
+          <a:blip r:embed="rId3"/>
+          <a:srcRect l="-43" r="-168" b="5204"/>
           <a:stretch>
             <a:fillRect/>
           </a:stretch>
         </p:blipFill>
         <p:spPr>
           <a:xfrm>
-            <a:off x="9337973" y="194225"/>
-            <a:ext cx="5087711" cy="7885250"/>
+            <a:off x="9144590" y="-2544"/>
+            <a:ext cx="5481351" cy="8232343"/>
           </a:xfrm>
           <a:prstGeom prst="rect">
             <a:avLst/>
@@ -3819,13 +3814,6 @@
   <p:clrMapOvr>
     <a:masterClrMapping/>
   </p:clrMapOvr>
-  <p:timing>
-    <p:tnLst>
-      <p:par>
-        <p:cTn id="1" dur="indefinite" restart="never" nodeType="tmRoot"/>
-      </p:par>
-    </p:tnLst>
-  </p:timing>
 </p:sld>
 </file>
 
@@ -3881,8 +3869,8 @@
         </p:nvSpPr>
         <p:spPr>
           <a:xfrm>
-            <a:off x="793790" y="2080718"/>
-            <a:ext cx="4987171" cy="620078"/>
+            <a:off x="840088" y="2057569"/>
+            <a:ext cx="5288113" cy="643227"/>
           </a:xfrm>
           <a:prstGeom prst="rect">
             <a:avLst/>
@@ -4198,13 +4186,6 @@
   <p:clrMapOvr>
     <a:masterClrMapping/>
   </p:clrMapOvr>
-  <p:timing>
-    <p:tnLst>
-      <p:par>
-        <p:cTn id="1" dur="indefinite" restart="never" nodeType="tmRoot"/>
-      </p:par>
-    </p:tnLst>
-  </p:timing>
 </p:sld>
 </file>
 
@@ -4392,7 +4373,7 @@
         <p:spPr>
           <a:xfrm>
             <a:off x="1083588" y="3191351"/>
-            <a:ext cx="2844998" cy="310158"/>
+            <a:ext cx="3018618" cy="310158"/>
           </a:xfrm>
           <a:prstGeom prst="rect">
             <a:avLst/>
@@ -4664,7 +4645,7 @@
         <p:spPr>
           <a:xfrm>
             <a:off x="9911001" y="3191351"/>
-            <a:ext cx="2480905" cy="310158"/>
+            <a:ext cx="2573502" cy="310158"/>
           </a:xfrm>
           <a:prstGeom prst="rect">
             <a:avLst/>
@@ -4682,7 +4663,7 @@
               </a:lnSpc>
             </a:pPr>
             <a:r>
-              <a:rPr lang="en-US" sz="1950" dirty="0" smtClean="0">
+              <a:rPr lang="en-US" sz="1950" dirty="0">
                 <a:solidFill>
                   <a:srgbClr val="454240"/>
                 </a:solidFill>
@@ -4693,7 +4674,7 @@
               <a:t>Interface do </a:t>
             </a:r>
             <a:r>
-              <a:rPr lang="en-US" sz="1950" dirty="0" err="1" smtClean="0">
+              <a:rPr lang="en-US" sz="1950" dirty="0" err="1">
                 <a:solidFill>
                   <a:srgbClr val="454240"/>
                 </a:solidFill>
@@ -4828,7 +4809,7 @@
               </a:lnSpc>
             </a:pPr>
             <a:r>
-              <a:rPr lang="en-US" sz="1950" dirty="0" err="1" smtClean="0">
+              <a:rPr lang="en-US" sz="1950" dirty="0" err="1">
                 <a:solidFill>
                   <a:srgbClr val="454240"/>
                 </a:solidFill>
@@ -4839,7 +4820,7 @@
               <a:t>Lógica</a:t>
             </a:r>
             <a:r>
-              <a:rPr lang="en-US" sz="1950" dirty="0" smtClean="0">
+              <a:rPr lang="en-US" sz="1950" dirty="0">
                 <a:solidFill>
                   <a:srgbClr val="454240"/>
                 </a:solidFill>
@@ -4850,7 +4831,7 @@
               <a:t> do </a:t>
             </a:r>
             <a:r>
-              <a:rPr lang="en-US" sz="1950" dirty="0" err="1" smtClean="0">
+              <a:rPr lang="en-US" sz="1950" dirty="0" err="1">
                 <a:solidFill>
                   <a:srgbClr val="454240"/>
                 </a:solidFill>
@@ -5093,13 +5074,6 @@
   <p:clrMapOvr>
     <a:masterClrMapping/>
   </p:clrMapOvr>
-  <p:timing>
-    <p:tnLst>
-      <p:par>
-        <p:cTn id="1" dur="indefinite" restart="never" nodeType="tmRoot"/>
-      </p:par>
-    </p:tnLst>
-  </p:timing>
 </p:sld>
 </file>
 
@@ -5171,7 +5145,7 @@
         <p:spPr>
           <a:xfrm>
             <a:off x="793790" y="2712006"/>
-            <a:ext cx="2773799" cy="310158"/>
+            <a:ext cx="2889545" cy="310158"/>
           </a:xfrm>
           <a:prstGeom prst="rect">
             <a:avLst/>
@@ -5656,13 +5630,6 @@
   <p:clrMapOvr>
     <a:masterClrMapping/>
   </p:clrMapOvr>
-  <p:timing>
-    <p:tnLst>
-      <p:par>
-        <p:cTn id="1" dur="indefinite" restart="never" nodeType="tmRoot"/>
-      </p:par>
-    </p:tnLst>
-  </p:timing>
 </p:sld>
 </file>
 
@@ -5785,14 +5752,6 @@
               </a:rPr>
               <a:t> </a:t>
             </a:r>
-            <a:endParaRPr lang="en-US" sz="2000" dirty="0" smtClean="0">
-              <a:solidFill>
-                <a:srgbClr val="454240"/>
-              </a:solidFill>
-              <a:latin typeface="DM Sans" pitchFamily="34" charset="0"/>
-              <a:ea typeface="DM Sans" pitchFamily="34" charset="-122"/>
-              <a:cs typeface="DM Sans" pitchFamily="34" charset="-120"/>
-            </a:endParaRPr>
           </a:p>
           <a:p>
             <a:pPr marL="0" indent="0" algn="l">
@@ -5802,7 +5761,7 @@
               <a:buNone/>
             </a:pPr>
             <a:r>
-              <a:rPr lang="en-US" sz="2000" dirty="0" smtClean="0">
+              <a:rPr lang="en-US" sz="2000" dirty="0">
                 <a:solidFill>
                   <a:srgbClr val="454240"/>
                 </a:solidFill>
@@ -5810,18 +5769,7 @@
                 <a:ea typeface="DM Sans" pitchFamily="34" charset="-122"/>
                 <a:cs typeface="DM Sans" pitchFamily="34" charset="-120"/>
               </a:rPr>
-              <a:t>do </a:t>
-            </a:r>
-            <a:r>
-              <a:rPr lang="en-US" sz="2000" dirty="0">
-                <a:solidFill>
-                  <a:srgbClr val="454240"/>
-                </a:solidFill>
-                <a:latin typeface="DM Sans" pitchFamily="34" charset="0"/>
-                <a:ea typeface="DM Sans" pitchFamily="34" charset="-122"/>
-                <a:cs typeface="DM Sans" pitchFamily="34" charset="-120"/>
-              </a:rPr>
-              <a:t>aplicativo mobile.</a:t>
+              <a:t>do aplicativo mobile.</a:t>
             </a:r>
             <a:endParaRPr lang="en-US" sz="2000" dirty="0"/>
           </a:p>
@@ -6088,71 +6036,86 @@
                 <a:solidFill>
                   <a:srgbClr val="454240"/>
                 </a:solidFill>
-                <a:latin typeface="DM Sans" pitchFamily="34" charset="0"/>
-                <a:ea typeface="DM Sans" pitchFamily="34" charset="-122"/>
-                <a:cs typeface="DM Sans" pitchFamily="34" charset="-120"/>
-              </a:rPr>
-              <a:t>Ambiente de execução para </a:t>
-            </a:r>
-            <a:r>
-              <a:rPr lang="en-US" dirty="0" smtClean="0">
-                <a:solidFill>
-                  <a:srgbClr val="454240"/>
-                </a:solidFill>
-                <a:latin typeface="DM Sans" pitchFamily="34" charset="0"/>
-                <a:ea typeface="DM Sans" pitchFamily="34" charset="-122"/>
-                <a:cs typeface="DM Sans" pitchFamily="34" charset="-120"/>
-              </a:rPr>
-              <a:t>a </a:t>
-            </a:r>
-          </a:p>
-          <a:p>
-            <a:pPr>
-              <a:lnSpc>
-                <a:spcPts val="2100"/>
-              </a:lnSpc>
-            </a:pPr>
-            <a:r>
-              <a:rPr lang="en-US" dirty="0" err="1" smtClean="0">
-                <a:solidFill>
-                  <a:srgbClr val="454240"/>
-                </a:solidFill>
-                <a:latin typeface="DM Sans" pitchFamily="34" charset="0"/>
-                <a:ea typeface="DM Sans" pitchFamily="34" charset="-122"/>
-                <a:cs typeface="DM Sans" pitchFamily="34" charset="-120"/>
-              </a:rPr>
-              <a:t>Lógica</a:t>
-            </a:r>
-            <a:r>
-              <a:rPr lang="en-US" dirty="0" smtClean="0">
-                <a:solidFill>
-                  <a:srgbClr val="454240"/>
-                </a:solidFill>
-                <a:latin typeface="DM Sans" pitchFamily="34" charset="0"/>
-                <a:ea typeface="DM Sans" pitchFamily="34" charset="-122"/>
-                <a:cs typeface="DM Sans" pitchFamily="34" charset="-120"/>
+                <a:latin typeface="DM Sans"/>
+              </a:rPr>
+              <a:t>Base do </a:t>
+            </a:r>
+            <a:r>
+              <a:rPr lang="en-US" dirty="0" err="1">
+                <a:solidFill>
+                  <a:srgbClr val="454240"/>
+                </a:solidFill>
+                <a:latin typeface="DM Sans"/>
+              </a:rPr>
+              <a:t>ambiente</a:t>
+            </a:r>
+            <a:r>
+              <a:rPr lang="en-US" dirty="0">
+                <a:solidFill>
+                  <a:srgbClr val="454240"/>
+                </a:solidFill>
+                <a:latin typeface="DM Sans"/>
               </a:rPr>
               <a:t> do </a:t>
             </a:r>
             <a:r>
-              <a:rPr lang="en-US" dirty="0" err="1" smtClean="0">
-                <a:solidFill>
-                  <a:srgbClr val="454240"/>
-                </a:solidFill>
-                <a:latin typeface="DM Sans" pitchFamily="34" charset="0"/>
-                <a:ea typeface="DM Sans" pitchFamily="34" charset="-122"/>
-                <a:cs typeface="DM Sans" pitchFamily="34" charset="-120"/>
-              </a:rPr>
-              <a:t>sistema</a:t>
-            </a:r>
-            <a:endParaRPr lang="en-US" dirty="0" smtClean="0">
+              <a:rPr lang="en-US" dirty="0" err="1">
+                <a:solidFill>
+                  <a:srgbClr val="454240"/>
+                </a:solidFill>
+                <a:latin typeface="DM Sans"/>
+              </a:rPr>
+              <a:t>projeto</a:t>
+            </a:r>
+            <a:endParaRPr lang="en-US">
               <a:solidFill>
                 <a:srgbClr val="454240"/>
               </a:solidFill>
-              <a:latin typeface="DM Sans" pitchFamily="34" charset="0"/>
-              <a:ea typeface="DM Sans" pitchFamily="34" charset="-122"/>
-              <a:cs typeface="DM Sans" pitchFamily="34" charset="-120"/>
+              <a:latin typeface="DM Sans"/>
             </a:endParaRPr>
+          </a:p>
+          <a:p>
+            <a:pPr>
+              <a:lnSpc>
+                <a:spcPts val="2100"/>
+              </a:lnSpc>
+            </a:pPr>
+            <a:r>
+              <a:rPr lang="en-US" dirty="0" err="1">
+                <a:solidFill>
+                  <a:srgbClr val="454240"/>
+                </a:solidFill>
+                <a:latin typeface="DM Sans"/>
+              </a:rPr>
+              <a:t>gerenciando</a:t>
+            </a:r>
+            <a:r>
+              <a:rPr lang="en-US" dirty="0">
+                <a:solidFill>
+                  <a:srgbClr val="454240"/>
+                </a:solidFill>
+                <a:latin typeface="DM Sans"/>
+              </a:rPr>
+              <a:t> </a:t>
+            </a:r>
+            <a:r>
+              <a:rPr lang="en-US" dirty="0" err="1">
+                <a:solidFill>
+                  <a:srgbClr val="454240"/>
+                </a:solidFill>
+                <a:latin typeface="DM Sans"/>
+              </a:rPr>
+              <a:t>dependências</a:t>
+            </a:r>
+            <a:r>
+              <a:rPr lang="en-US" dirty="0">
+                <a:solidFill>
+                  <a:srgbClr val="454240"/>
+                </a:solidFill>
+                <a:latin typeface="DM Sans"/>
+              </a:rPr>
+              <a:t> e scripts</a:t>
+            </a:r>
           </a:p>
         </p:txBody>
       </p:sp>
@@ -6821,7 +6784,7 @@
               </a:lnSpc>
             </a:pPr>
             <a:r>
-              <a:rPr lang="en-US" dirty="0" err="1" smtClean="0">
+              <a:rPr lang="en-US" dirty="0" err="1">
                 <a:solidFill>
                   <a:srgbClr val="454240"/>
                 </a:solidFill>
@@ -6832,7 +6795,7 @@
               <a:t>Lógica</a:t>
             </a:r>
             <a:r>
-              <a:rPr lang="en-US" dirty="0" smtClean="0">
+              <a:rPr lang="en-US" dirty="0">
                 <a:solidFill>
                   <a:srgbClr val="454240"/>
                 </a:solidFill>
@@ -6843,7 +6806,7 @@
               <a:t> do </a:t>
             </a:r>
             <a:r>
-              <a:rPr lang="en-US" dirty="0" err="1" smtClean="0">
+              <a:rPr lang="en-US" dirty="0" err="1">
                 <a:solidFill>
                   <a:srgbClr val="454240"/>
                 </a:solidFill>
@@ -6854,7 +6817,7 @@
               <a:t>sistema</a:t>
             </a:r>
             <a:r>
-              <a:rPr lang="en-US" dirty="0" smtClean="0">
+              <a:rPr lang="en-US" dirty="0">
                 <a:solidFill>
                   <a:srgbClr val="454240"/>
                 </a:solidFill>
@@ -6865,7 +6828,7 @@
               <a:t> </a:t>
             </a:r>
             <a:r>
-              <a:rPr lang="en-US" dirty="0" err="1" smtClean="0">
+              <a:rPr lang="en-US" dirty="0" err="1">
                 <a:solidFill>
                   <a:srgbClr val="454240"/>
                 </a:solidFill>
@@ -6876,7 +6839,7 @@
               <a:t>como</a:t>
             </a:r>
             <a:r>
-              <a:rPr lang="en-US" dirty="0" smtClean="0">
+              <a:rPr lang="en-US" dirty="0">
                 <a:solidFill>
                   <a:srgbClr val="454240"/>
                 </a:solidFill>
@@ -6884,18 +6847,7 @@
                 <a:ea typeface="DM Sans" pitchFamily="34" charset="-122"/>
                 <a:cs typeface="DM Sans" pitchFamily="34" charset="-120"/>
               </a:rPr>
-              <a:t> </a:t>
-            </a:r>
-            <a:r>
-              <a:rPr lang="en-US" dirty="0">
-                <a:solidFill>
-                  <a:srgbClr val="454240"/>
-                </a:solidFill>
-                <a:latin typeface="DM Sans" pitchFamily="34" charset="0"/>
-                <a:ea typeface="DM Sans" pitchFamily="34" charset="-122"/>
-                <a:cs typeface="DM Sans" pitchFamily="34" charset="-120"/>
-              </a:rPr>
-              <a:t>serviço: autenticação, banco de dados e hospedagem.</a:t>
+              <a:t> serviço: autenticação, banco de dados e hospedagem.</a:t>
             </a:r>
             <a:endParaRPr lang="en-US" dirty="0"/>
           </a:p>
@@ -6952,13 +6904,6 @@
   <p:clrMapOvr>
     <a:masterClrMapping/>
   </p:clrMapOvr>
-  <p:timing>
-    <p:tnLst>
-      <p:par>
-        <p:cTn id="1" dur="indefinite" restart="never" nodeType="tmRoot"/>
-      </p:par>
-    </p:tnLst>
-  </p:timing>
 </p:sld>
 </file>
 
@@ -7136,13 +7081,6 @@
   <p:clrMapOvr>
     <a:masterClrMapping/>
   </p:clrMapOvr>
-  <p:timing>
-    <p:tnLst>
-      <p:par>
-        <p:cTn id="1" dur="indefinite" restart="never" nodeType="tmRoot"/>
-      </p:par>
-    </p:tnLst>
-  </p:timing>
 </p:sld>
 </file>
 
@@ -7345,17 +7283,41 @@
               <a:buChar char="•"/>
             </a:pPr>
             <a:r>
+              <a:rPr lang="en-US" dirty="0" err="1">
+                <a:solidFill>
+                  <a:srgbClr val="000000"/>
+                </a:solidFill>
+                <a:latin typeface="DM Sans"/>
+                <a:ea typeface="DM Sans" pitchFamily="34" charset="-122"/>
+                <a:cs typeface="DM Sans" pitchFamily="34" charset="-120"/>
+              </a:rPr>
+              <a:t>Cadastro</a:t>
+            </a:r>
+            <a:r>
               <a:rPr lang="en-US" dirty="0">
                 <a:solidFill>
                   <a:srgbClr val="000000"/>
                 </a:solidFill>
-                <a:latin typeface="DM Sans" pitchFamily="34" charset="0"/>
-                <a:ea typeface="DM Sans" pitchFamily="34" charset="-122"/>
-                <a:cs typeface="DM Sans" pitchFamily="34" charset="-120"/>
-              </a:rPr>
-              <a:t>Cadastro e login com e-mail e senha</a:t>
-            </a:r>
-            <a:endParaRPr lang="en-US" dirty="0"/>
+                <a:latin typeface="DM Sans"/>
+                <a:ea typeface="DM Sans" pitchFamily="34" charset="-122"/>
+                <a:cs typeface="DM Sans" pitchFamily="34" charset="-120"/>
+              </a:rPr>
+              <a:t> e login com e-mail e </a:t>
+            </a:r>
+            <a:r>
+              <a:rPr lang="en-US" dirty="0" err="1">
+                <a:solidFill>
+                  <a:srgbClr val="000000"/>
+                </a:solidFill>
+                <a:latin typeface="DM Sans"/>
+                <a:ea typeface="DM Sans" pitchFamily="34" charset="-122"/>
+                <a:cs typeface="DM Sans" pitchFamily="34" charset="-120"/>
+              </a:rPr>
+              <a:t>senha</a:t>
+            </a:r>
+            <a:endParaRPr lang="en-US" dirty="0" err="1">
+              <a:latin typeface="DM Sans"/>
+            </a:endParaRPr>
           </a:p>
           <a:p>
             <a:pPr marL="342900" indent="-342900" algn="l">
@@ -7370,13 +7332,37 @@
                 <a:solidFill>
                   <a:srgbClr val="000000"/>
                 </a:solidFill>
-                <a:latin typeface="DM Sans" pitchFamily="34" charset="0"/>
-                <a:ea typeface="DM Sans" pitchFamily="34" charset="-122"/>
-                <a:cs typeface="DM Sans" pitchFamily="34" charset="-120"/>
-              </a:rPr>
-              <a:t>Login com conta Google</a:t>
-            </a:r>
-            <a:endParaRPr lang="en-US" dirty="0"/>
+                <a:latin typeface="DM Sans"/>
+                <a:ea typeface="DM Sans" pitchFamily="34" charset="-122"/>
+                <a:cs typeface="DM Sans" pitchFamily="34" charset="-120"/>
+              </a:rPr>
+              <a:t>Login com </a:t>
+            </a:r>
+            <a:r>
+              <a:rPr lang="en-US" dirty="0" err="1">
+                <a:solidFill>
+                  <a:srgbClr val="000000"/>
+                </a:solidFill>
+                <a:latin typeface="DM Sans"/>
+                <a:ea typeface="DM Sans" pitchFamily="34" charset="-122"/>
+                <a:cs typeface="DM Sans" pitchFamily="34" charset="-120"/>
+              </a:rPr>
+              <a:t>conta</a:t>
+            </a:r>
+            <a:r>
+              <a:rPr lang="en-US" dirty="0">
+                <a:solidFill>
+                  <a:srgbClr val="000000"/>
+                </a:solidFill>
+                <a:latin typeface="DM Sans"/>
+                <a:ea typeface="DM Sans" pitchFamily="34" charset="-122"/>
+                <a:cs typeface="DM Sans" pitchFamily="34" charset="-120"/>
+              </a:rPr>
+              <a:t> Google</a:t>
+            </a:r>
+            <a:endParaRPr lang="en-US" dirty="0">
+              <a:latin typeface="DM Sans"/>
+            </a:endParaRPr>
           </a:p>
           <a:p>
             <a:pPr marL="342900" indent="-342900" algn="l">
@@ -7387,17 +7373,41 @@
               <a:buChar char="•"/>
             </a:pPr>
             <a:r>
+              <a:rPr lang="en-US" dirty="0" err="1">
+                <a:solidFill>
+                  <a:srgbClr val="000000"/>
+                </a:solidFill>
+                <a:latin typeface="DM Sans"/>
+                <a:ea typeface="DM Sans" pitchFamily="34" charset="-122"/>
+                <a:cs typeface="DM Sans" pitchFamily="34" charset="-120"/>
+              </a:rPr>
+              <a:t>Recuperação</a:t>
+            </a:r>
+            <a:r>
               <a:rPr lang="en-US" dirty="0">
                 <a:solidFill>
                   <a:srgbClr val="000000"/>
                 </a:solidFill>
-                <a:latin typeface="DM Sans" pitchFamily="34" charset="0"/>
-                <a:ea typeface="DM Sans" pitchFamily="34" charset="-122"/>
-                <a:cs typeface="DM Sans" pitchFamily="34" charset="-120"/>
-              </a:rPr>
-              <a:t>Recuperação de senha</a:t>
-            </a:r>
-            <a:endParaRPr lang="en-US" dirty="0"/>
+                <a:latin typeface="DM Sans"/>
+                <a:ea typeface="DM Sans" pitchFamily="34" charset="-122"/>
+                <a:cs typeface="DM Sans" pitchFamily="34" charset="-120"/>
+              </a:rPr>
+              <a:t> de </a:t>
+            </a:r>
+            <a:r>
+              <a:rPr lang="en-US" dirty="0" err="1">
+                <a:solidFill>
+                  <a:srgbClr val="000000"/>
+                </a:solidFill>
+                <a:latin typeface="DM Sans"/>
+                <a:ea typeface="DM Sans" pitchFamily="34" charset="-122"/>
+                <a:cs typeface="DM Sans" pitchFamily="34" charset="-120"/>
+              </a:rPr>
+              <a:t>senha</a:t>
+            </a:r>
+            <a:endParaRPr lang="en-US" dirty="0" err="1">
+              <a:latin typeface="DM Sans"/>
+            </a:endParaRPr>
           </a:p>
           <a:p>
             <a:pPr marL="342900" indent="-342900" algn="l">
@@ -7408,17 +7418,74 @@
               <a:buChar char="•"/>
             </a:pPr>
             <a:r>
+              <a:rPr lang="en-US" dirty="0" err="1">
+                <a:solidFill>
+                  <a:srgbClr val="000000"/>
+                </a:solidFill>
+                <a:latin typeface="DM Sans"/>
+                <a:ea typeface="DM Sans" pitchFamily="34" charset="-122"/>
+                <a:cs typeface="DM Sans" pitchFamily="34" charset="-120"/>
+              </a:rPr>
+              <a:t>Manutenção</a:t>
+            </a:r>
+            <a:r>
               <a:rPr lang="en-US" dirty="0">
                 <a:solidFill>
                   <a:srgbClr val="000000"/>
                 </a:solidFill>
-                <a:latin typeface="DM Sans" pitchFamily="34" charset="0"/>
-                <a:ea typeface="DM Sans" pitchFamily="34" charset="-122"/>
-                <a:cs typeface="DM Sans" pitchFamily="34" charset="-120"/>
-              </a:rPr>
-              <a:t>Manutenção de sessão (login persistente)</a:t>
-            </a:r>
-            <a:endParaRPr lang="en-US" dirty="0"/>
+                <a:latin typeface="DM Sans"/>
+                <a:ea typeface="DM Sans" pitchFamily="34" charset="-122"/>
+                <a:cs typeface="DM Sans" pitchFamily="34" charset="-120"/>
+              </a:rPr>
+              <a:t> de </a:t>
+            </a:r>
+            <a:r>
+              <a:rPr lang="en-US" dirty="0" err="1">
+                <a:solidFill>
+                  <a:srgbClr val="000000"/>
+                </a:solidFill>
+                <a:latin typeface="DM Sans"/>
+                <a:ea typeface="DM Sans" pitchFamily="34" charset="-122"/>
+                <a:cs typeface="DM Sans" pitchFamily="34" charset="-120"/>
+              </a:rPr>
+              <a:t>sessão</a:t>
+            </a:r>
+            <a:r>
+              <a:rPr lang="en-US" dirty="0">
+                <a:solidFill>
+                  <a:srgbClr val="000000"/>
+                </a:solidFill>
+                <a:latin typeface="DM Sans"/>
+                <a:ea typeface="DM Sans" pitchFamily="34" charset="-122"/>
+                <a:cs typeface="DM Sans" pitchFamily="34" charset="-120"/>
+              </a:rPr>
+              <a:t> (login </a:t>
+            </a:r>
+            <a:r>
+              <a:rPr lang="en-US" dirty="0" err="1">
+                <a:solidFill>
+                  <a:srgbClr val="000000"/>
+                </a:solidFill>
+                <a:latin typeface="DM Sans"/>
+                <a:ea typeface="DM Sans" pitchFamily="34" charset="-122"/>
+                <a:cs typeface="DM Sans" pitchFamily="34" charset="-120"/>
+              </a:rPr>
+              <a:t>persistente</a:t>
+            </a:r>
+            <a:r>
+              <a:rPr lang="en-US" dirty="0">
+                <a:solidFill>
+                  <a:srgbClr val="000000"/>
+                </a:solidFill>
+                <a:latin typeface="DM Sans"/>
+                <a:ea typeface="DM Sans" pitchFamily="34" charset="-122"/>
+                <a:cs typeface="DM Sans" pitchFamily="34" charset="-120"/>
+              </a:rPr>
+              <a:t>)</a:t>
+            </a:r>
+            <a:endParaRPr lang="en-US" dirty="0">
+              <a:latin typeface="DM Sans"/>
+            </a:endParaRPr>
           </a:p>
           <a:p>
             <a:pPr marL="342900" indent="-342900" algn="l">
@@ -7433,13 +7500,26 @@
                 <a:solidFill>
                   <a:srgbClr val="000000"/>
                 </a:solidFill>
-                <a:latin typeface="DM Sans" pitchFamily="34" charset="0"/>
-                <a:ea typeface="DM Sans" pitchFamily="34" charset="-122"/>
-                <a:cs typeface="DM Sans" pitchFamily="34" charset="-120"/>
-              </a:rPr>
-              <a:t>Logout do sistema</a:t>
-            </a:r>
-            <a:endParaRPr lang="en-US" dirty="0"/>
+                <a:latin typeface="DM Sans"/>
+                <a:ea typeface="DM Sans" pitchFamily="34" charset="-122"/>
+                <a:cs typeface="DM Sans" pitchFamily="34" charset="-120"/>
+              </a:rPr>
+              <a:t>Logout do </a:t>
+            </a:r>
+            <a:r>
+              <a:rPr lang="en-US" dirty="0" err="1">
+                <a:solidFill>
+                  <a:srgbClr val="000000"/>
+                </a:solidFill>
+                <a:latin typeface="DM Sans"/>
+                <a:ea typeface="DM Sans" pitchFamily="34" charset="-122"/>
+                <a:cs typeface="DM Sans" pitchFamily="34" charset="-120"/>
+              </a:rPr>
+              <a:t>sistema</a:t>
+            </a:r>
+            <a:endParaRPr lang="en-US" dirty="0" err="1">
+              <a:latin typeface="DM Sans"/>
+            </a:endParaRPr>
           </a:p>
           <a:p>
             <a:pPr marL="342900" indent="-342900" algn="l">
@@ -7454,13 +7534,125 @@
                 <a:solidFill>
                   <a:srgbClr val="000000"/>
                 </a:solidFill>
-                <a:latin typeface="DM Sans" pitchFamily="34" charset="0"/>
-                <a:ea typeface="DM Sans" pitchFamily="34" charset="-122"/>
-                <a:cs typeface="DM Sans" pitchFamily="34" charset="-120"/>
-              </a:rPr>
-              <a:t>Controle de acesso a recursos personalizados (favoritos, perfil)</a:t>
-            </a:r>
-            <a:endParaRPr lang="en-US" dirty="0"/>
+                <a:latin typeface="DM Sans"/>
+                <a:ea typeface="DM Sans" pitchFamily="34" charset="-122"/>
+                <a:cs typeface="DM Sans" pitchFamily="34" charset="-120"/>
+              </a:rPr>
+              <a:t>Controle de </a:t>
+            </a:r>
+            <a:r>
+              <a:rPr lang="en-US" dirty="0" err="1">
+                <a:solidFill>
+                  <a:srgbClr val="000000"/>
+                </a:solidFill>
+                <a:latin typeface="DM Sans"/>
+                <a:ea typeface="DM Sans" pitchFamily="34" charset="-122"/>
+                <a:cs typeface="DM Sans" pitchFamily="34" charset="-120"/>
+              </a:rPr>
+              <a:t>acesso</a:t>
+            </a:r>
+            <a:r>
+              <a:rPr lang="en-US" dirty="0">
+                <a:solidFill>
+                  <a:srgbClr val="000000"/>
+                </a:solidFill>
+                <a:latin typeface="DM Sans"/>
+                <a:ea typeface="DM Sans" pitchFamily="34" charset="-122"/>
+                <a:cs typeface="DM Sans" pitchFamily="34" charset="-120"/>
+              </a:rPr>
+              <a:t> a </a:t>
+            </a:r>
+            <a:r>
+              <a:rPr lang="en-US" dirty="0" err="1">
+                <a:solidFill>
+                  <a:srgbClr val="000000"/>
+                </a:solidFill>
+                <a:latin typeface="DM Sans"/>
+                <a:ea typeface="DM Sans" pitchFamily="34" charset="-122"/>
+                <a:cs typeface="DM Sans" pitchFamily="34" charset="-120"/>
+              </a:rPr>
+              <a:t>recursos</a:t>
+            </a:r>
+            <a:r>
+              <a:rPr lang="en-US" dirty="0">
+                <a:solidFill>
+                  <a:srgbClr val="000000"/>
+                </a:solidFill>
+                <a:latin typeface="DM Sans"/>
+                <a:ea typeface="DM Sans" pitchFamily="34" charset="-122"/>
+                <a:cs typeface="DM Sans" pitchFamily="34" charset="-120"/>
+              </a:rPr>
+              <a:t> </a:t>
+            </a:r>
+            <a:r>
+              <a:rPr lang="en-US" dirty="0" err="1">
+                <a:solidFill>
+                  <a:srgbClr val="000000"/>
+                </a:solidFill>
+                <a:latin typeface="DM Sans"/>
+                <a:ea typeface="DM Sans" pitchFamily="34" charset="-122"/>
+                <a:cs typeface="DM Sans" pitchFamily="34" charset="-120"/>
+              </a:rPr>
+              <a:t>personalizados</a:t>
+            </a:r>
+            <a:r>
+              <a:rPr lang="en-US" dirty="0">
+                <a:solidFill>
+                  <a:srgbClr val="000000"/>
+                </a:solidFill>
+                <a:latin typeface="DM Sans"/>
+                <a:ea typeface="DM Sans" pitchFamily="34" charset="-122"/>
+                <a:cs typeface="DM Sans" pitchFamily="34" charset="-120"/>
+              </a:rPr>
+              <a:t> (</a:t>
+            </a:r>
+            <a:r>
+              <a:rPr lang="en-US" dirty="0" err="1">
+                <a:solidFill>
+                  <a:srgbClr val="000000"/>
+                </a:solidFill>
+                <a:latin typeface="DM Sans"/>
+                <a:ea typeface="DM Sans" pitchFamily="34" charset="-122"/>
+                <a:cs typeface="DM Sans" pitchFamily="34" charset="-120"/>
+              </a:rPr>
+              <a:t>favoritos</a:t>
+            </a:r>
+            <a:r>
+              <a:rPr lang="en-US" dirty="0">
+                <a:solidFill>
+                  <a:srgbClr val="000000"/>
+                </a:solidFill>
+                <a:latin typeface="DM Sans"/>
+                <a:ea typeface="DM Sans" pitchFamily="34" charset="-122"/>
+                <a:cs typeface="DM Sans" pitchFamily="34" charset="-120"/>
+              </a:rPr>
+              <a:t>, </a:t>
+            </a:r>
+            <a:r>
+              <a:rPr lang="en-US" dirty="0" err="1">
+                <a:solidFill>
+                  <a:srgbClr val="000000"/>
+                </a:solidFill>
+                <a:latin typeface="DM Sans"/>
+                <a:ea typeface="DM Sans" pitchFamily="34" charset="-122"/>
+                <a:cs typeface="DM Sans" pitchFamily="34" charset="-120"/>
+              </a:rPr>
+              <a:t>perfil</a:t>
+            </a:r>
+            <a:r>
+              <a:rPr lang="en-US" dirty="0">
+                <a:solidFill>
+                  <a:srgbClr val="000000"/>
+                </a:solidFill>
+                <a:latin typeface="DM Sans"/>
+                <a:ea typeface="DM Sans" pitchFamily="34" charset="-122"/>
+                <a:cs typeface="DM Sans" pitchFamily="34" charset="-120"/>
+              </a:rPr>
+              <a:t>)</a:t>
+            </a:r>
+            <a:endParaRPr lang="en-US" dirty="0">
+              <a:latin typeface="DM Sans"/>
+            </a:endParaRPr>
           </a:p>
         </p:txBody>
       </p:sp>
@@ -7473,7 +7665,7 @@
         <p:spPr>
           <a:xfrm>
             <a:off x="7564874" y="2850833"/>
-            <a:ext cx="3385899" cy="310158"/>
+            <a:ext cx="3420623" cy="310158"/>
           </a:xfrm>
           <a:prstGeom prst="rect">
             <a:avLst/>
@@ -7557,7 +7749,7 @@
         <p:spPr>
           <a:xfrm>
             <a:off x="7564874" y="4391386"/>
-            <a:ext cx="6279356" cy="1795939"/>
+            <a:ext cx="6279356" cy="1066734"/>
           </a:xfrm>
           <a:prstGeom prst="rect">
             <a:avLst/>
@@ -7581,24 +7773,51 @@
                 <a:solidFill>
                   <a:srgbClr val="454240"/>
                 </a:solidFill>
-                <a:latin typeface="DM Sans" pitchFamily="34" charset="0"/>
-                <a:ea typeface="DM Sans" pitchFamily="34" charset="-122"/>
-                <a:cs typeface="DM Sans" pitchFamily="34" charset="-120"/>
-              </a:rPr>
-              <a:t>Plugins locais:</a:t>
+                <a:latin typeface="DM Sans"/>
+                <a:ea typeface="DM Sans" pitchFamily="34" charset="-122"/>
+                <a:cs typeface="DM Sans" pitchFamily="34" charset="-120"/>
+              </a:rPr>
+              <a:t>Plugin </a:t>
+            </a:r>
+            <a:r>
+              <a:rPr lang="en-US" b="1">
+                <a:solidFill>
+                  <a:srgbClr val="454240"/>
+                </a:solidFill>
+                <a:latin typeface="DM Sans"/>
+                <a:ea typeface="DM Sans" pitchFamily="34" charset="-122"/>
+                <a:cs typeface="DM Sans" pitchFamily="34" charset="-120"/>
+              </a:rPr>
+              <a:t>local</a:t>
+            </a:r>
+            <a:r>
+              <a:rPr lang="en-US" b="1" dirty="0">
+                <a:solidFill>
+                  <a:srgbClr val="454240"/>
+                </a:solidFill>
+                <a:latin typeface="DM Sans"/>
+                <a:ea typeface="DM Sans" pitchFamily="34" charset="-122"/>
+                <a:cs typeface="DM Sans" pitchFamily="34" charset="-120"/>
+              </a:rPr>
+              <a:t>:</a:t>
             </a:r>
             <a:r>
               <a:rPr lang="en-US" dirty="0">
                 <a:solidFill>
                   <a:srgbClr val="454240"/>
                 </a:solidFill>
-                <a:latin typeface="DM Sans" pitchFamily="34" charset="0"/>
-                <a:ea typeface="DM Sans" pitchFamily="34" charset="-122"/>
-                <a:cs typeface="DM Sans" pitchFamily="34" charset="-120"/>
-              </a:rPr>
-              <a:t> Ionic Storage, Preferences e SQLite</a:t>
-            </a:r>
-            <a:endParaRPr lang="en-US" dirty="0"/>
+                <a:latin typeface="DM Sans"/>
+                <a:ea typeface="DM Sans" pitchFamily="34" charset="-122"/>
+                <a:cs typeface="DM Sans" pitchFamily="34" charset="-120"/>
+              </a:rPr>
+              <a:t> Ionic Storage</a:t>
+            </a:r>
+            <a:endParaRPr lang="en-US" dirty="0">
+              <a:solidFill>
+                <a:srgbClr val="454240"/>
+              </a:solidFill>
+              <a:latin typeface="DM Sans"/>
+            </a:endParaRPr>
           </a:p>
           <a:p>
             <a:pPr marL="342900" indent="-342900" algn="l">
@@ -7609,92 +7828,85 @@
               <a:buChar char="•"/>
             </a:pPr>
             <a:r>
+              <a:rPr lang="en-US" b="1" dirty="0" err="1">
+                <a:solidFill>
+                  <a:srgbClr val="454240"/>
+                </a:solidFill>
+                <a:latin typeface="DM Sans"/>
+                <a:ea typeface="DM Sans" pitchFamily="34" charset="-122"/>
+                <a:cs typeface="DM Sans" pitchFamily="34" charset="-120"/>
+              </a:rPr>
+              <a:t>Nuvem</a:t>
+            </a:r>
+            <a:r>
               <a:rPr lang="en-US" b="1" dirty="0">
                 <a:solidFill>
                   <a:srgbClr val="454240"/>
                 </a:solidFill>
-                <a:latin typeface="DM Sans" pitchFamily="34" charset="0"/>
-                <a:ea typeface="DM Sans" pitchFamily="34" charset="-122"/>
-                <a:cs typeface="DM Sans" pitchFamily="34" charset="-120"/>
-              </a:rPr>
-              <a:t>Arquivos:</a:t>
+                <a:latin typeface="DM Sans"/>
+                <a:ea typeface="DM Sans" pitchFamily="34" charset="-122"/>
+                <a:cs typeface="DM Sans" pitchFamily="34" charset="-120"/>
+              </a:rPr>
+              <a:t>:</a:t>
             </a:r>
             <a:r>
               <a:rPr lang="en-US" dirty="0">
                 <a:solidFill>
                   <a:srgbClr val="454240"/>
                 </a:solidFill>
-                <a:latin typeface="DM Sans" pitchFamily="34" charset="0"/>
-                <a:ea typeface="DM Sans" pitchFamily="34" charset="-122"/>
-                <a:cs typeface="DM Sans" pitchFamily="34" charset="-120"/>
-              </a:rPr>
-              <a:t> FileSystem com formatos CSV e JSON</a:t>
-            </a:r>
-            <a:endParaRPr lang="en-US" dirty="0"/>
-          </a:p>
-          <a:p>
-            <a:pPr marL="342900" indent="-342900" algn="l">
-              <a:lnSpc>
-                <a:spcPts val="2500"/>
-              </a:lnSpc>
-              <a:buSzPct val="100000"/>
-              <a:buChar char="•"/>
-            </a:pPr>
-            <a:r>
-              <a:rPr lang="en-US" b="1" dirty="0">
-                <a:solidFill>
-                  <a:srgbClr val="454240"/>
-                </a:solidFill>
-                <a:latin typeface="DM Sans" pitchFamily="34" charset="0"/>
-                <a:ea typeface="DM Sans" pitchFamily="34" charset="-122"/>
-                <a:cs typeface="DM Sans" pitchFamily="34" charset="-120"/>
-              </a:rPr>
-              <a:t>Nuvem:</a:t>
+                <a:latin typeface="DM Sans"/>
+                <a:ea typeface="DM Sans" pitchFamily="34" charset="-122"/>
+                <a:cs typeface="DM Sans" pitchFamily="34" charset="-120"/>
+              </a:rPr>
+              <a:t> Firebase </a:t>
+            </a:r>
+            <a:r>
+              <a:rPr lang="en-US" dirty="0" err="1">
+                <a:solidFill>
+                  <a:srgbClr val="454240"/>
+                </a:solidFill>
+                <a:latin typeface="DM Sans"/>
+                <a:ea typeface="DM Sans" pitchFamily="34" charset="-122"/>
+                <a:cs typeface="DM Sans" pitchFamily="34" charset="-120"/>
+              </a:rPr>
+              <a:t>como</a:t>
             </a:r>
             <a:r>
               <a:rPr lang="en-US" dirty="0">
                 <a:solidFill>
                   <a:srgbClr val="454240"/>
                 </a:solidFill>
-                <a:latin typeface="DM Sans" pitchFamily="34" charset="0"/>
-                <a:ea typeface="DM Sans" pitchFamily="34" charset="-122"/>
-                <a:cs typeface="DM Sans" pitchFamily="34" charset="-120"/>
-              </a:rPr>
-              <a:t> Firebase como back-end de dados em tempo real</a:t>
-            </a:r>
-            <a:endParaRPr lang="en-US" dirty="0"/>
-          </a:p>
-          <a:p>
-            <a:pPr marL="342900" indent="-342900" algn="l">
-              <a:lnSpc>
-                <a:spcPts val="2500"/>
-              </a:lnSpc>
-              <a:buSzPct val="100000"/>
-              <a:buChar char="•"/>
-            </a:pPr>
-            <a:r>
-              <a:rPr lang="en-US" b="1" dirty="0">
-                <a:solidFill>
-                  <a:srgbClr val="454240"/>
-                </a:solidFill>
-                <a:latin typeface="DM Sans" pitchFamily="34" charset="0"/>
-                <a:ea typeface="DM Sans" pitchFamily="34" charset="-122"/>
-                <a:cs typeface="DM Sans" pitchFamily="34" charset="-120"/>
-              </a:rPr>
-              <a:t>Modelo ER:</a:t>
+                <a:latin typeface="DM Sans"/>
+                <a:ea typeface="DM Sans" pitchFamily="34" charset="-122"/>
+                <a:cs typeface="DM Sans" pitchFamily="34" charset="-120"/>
+              </a:rPr>
+              <a:t> back-end de dados </a:t>
+            </a:r>
+            <a:r>
+              <a:rPr lang="en-US" dirty="0" err="1">
+                <a:solidFill>
+                  <a:srgbClr val="454240"/>
+                </a:solidFill>
+                <a:latin typeface="DM Sans"/>
+                <a:ea typeface="DM Sans" pitchFamily="34" charset="-122"/>
+                <a:cs typeface="DM Sans" pitchFamily="34" charset="-120"/>
+              </a:rPr>
+              <a:t>em</a:t>
             </a:r>
             <a:r>
               <a:rPr lang="en-US" dirty="0">
                 <a:solidFill>
                   <a:srgbClr val="454240"/>
                 </a:solidFill>
-                <a:latin typeface="DM Sans" pitchFamily="34" charset="0"/>
-                <a:ea typeface="DM Sans" pitchFamily="34" charset="-122"/>
-                <a:cs typeface="DM Sans" pitchFamily="34" charset="-120"/>
-              </a:rPr>
-              <a:t> Diagrama do banco de dados estruturado para livros, usuários e avaliações</a:t>
-            </a:r>
-            <a:endParaRPr lang="en-US" dirty="0"/>
+                <a:latin typeface="DM Sans"/>
+                <a:ea typeface="DM Sans" pitchFamily="34" charset="-122"/>
+                <a:cs typeface="DM Sans" pitchFamily="34" charset="-120"/>
+              </a:rPr>
+              <a:t> tempo real</a:t>
+            </a:r>
+            <a:endParaRPr lang="en-US" dirty="0">
+              <a:latin typeface="DM Sans"/>
+            </a:endParaRPr>
           </a:p>
         </p:txBody>
       </p:sp>
@@ -7749,13 +7961,6 @@
   <p:clrMapOvr>
     <a:masterClrMapping/>
   </p:clrMapOvr>
-  <p:timing>
-    <p:tnLst>
-      <p:par>
-        <p:cTn id="1" dur="indefinite" restart="never" nodeType="tmRoot"/>
-      </p:par>
-    </p:tnLst>
-  </p:timing>
 </p:sld>
 </file>
 
@@ -8438,13 +8643,6 @@
   <p:clrMapOvr>
     <a:masterClrMapping/>
   </p:clrMapOvr>
-  <p:timing>
-    <p:tnLst>
-      <p:par>
-        <p:cTn id="1" dur="indefinite" restart="never" nodeType="tmRoot"/>
-      </p:par>
-    </p:tnLst>
-  </p:timing>
 </p:sld>
 </file>
 
@@ -8737,7 +8935,7 @@
   <a:extraClrSchemeLst/>
   <a:extLst>
     <a:ext uri="{05A4C25C-085E-4340-85A3-A5531E510DB2}">
-      <thm15:themeFamily xmlns="" xmlns:thm15="http://schemas.microsoft.com/office/thememl/2012/main" name="Office Theme" id="{62F939B6-93AF-4DB8-9C6B-D6C7DFDC589F}" vid="{4A3C46E8-61CC-4603-A589-7422A47A8E4A}"/>
+      <thm15:themeFamily xmlns:thm15="http://schemas.microsoft.com/office/thememl/2012/main" name="Office Theme" id="{62F939B6-93AF-4DB8-9C6B-D6C7DFDC589F}" vid="{4A3C46E8-61CC-4603-A589-7422A47A8E4A}"/>
     </a:ext>
   </a:extLst>
 </a:theme>

</xml_diff>